<commit_message>
Fill in student name and group on title slide
Co-Authored-By: Claude Sonnet 5.5 <noreply@anthropic.com>
Claude-Session: https://claude.ai/code/session_0119SPq8eRKyTVqhrTEFqUAc
</commit_message>
<xml_diff>
--- a/out/Безопасность_на_Крайнем_Севере.pptx
+++ b/out/Безопасность_на_Крайнем_Севере.pptx
@@ -5219,7 +5219,7 @@
                 <a:latin typeface="Times New Roman" panose="02020603050405020304" pitchFamily="18" charset="0"/>
                 <a:cs typeface="Times New Roman" panose="02020603050405020304" pitchFamily="18" charset="0"/>
               </a:rPr>
-              <a:t>студент группы ___________</a:t>
+              <a:t>студент группы 202</a:t>
             </a:r>
           </a:p>
           <a:p>
@@ -5231,7 +5231,7 @@
                 <a:latin typeface="Times New Roman" panose="02020603050405020304" pitchFamily="18" charset="0"/>
                 <a:cs typeface="Times New Roman" panose="02020603050405020304" pitchFamily="18" charset="0"/>
               </a:rPr>
-              <a:t>_____________________________</a:t>
+              <a:t>Некрасов Егор</a:t>
             </a:r>
           </a:p>
           <a:p>
@@ -5243,7 +5243,7 @@
                 <a:latin typeface="Times New Roman" panose="02020603050405020304" pitchFamily="18" charset="0"/>
                 <a:cs typeface="Times New Roman" panose="02020603050405020304" pitchFamily="18" charset="0"/>
               </a:rPr>
-              <a:t>ФИО</a:t>
+              <a:t/>
             </a:r>
             <a:endParaRPr lang="ru-RU" dirty="0">
               <a:solidFill>

</xml_diff>

<commit_message>
Add speaker notes with talk script to all slides
Co-Authored-By: Claude Sonnet 5.5 <noreply@anthropic.com>
Claude-Session: https://claude.ai/code/session_0119SPq8eRKyTVqhrTEFqUAc
</commit_message>
<xml_diff>
--- a/out/Безопасность_на_Крайнем_Севере.pptx
+++ b/out/Безопасность_на_Крайнем_Севере.pptx
@@ -738,6 +738,916 @@
     </a:lvl9pPr>
   </p:notesStyle>
 </p:notesMaster>
+</file>
+
+<file path=ppt/notesSlides/notesSlide14.xml><?xml version="1.0" encoding="utf-8"?>
+<p:notes xmlns:a="http://schemas.openxmlformats.org/drawingml/2006/main" xmlns:p="http://schemas.openxmlformats.org/presentationml/2006/main" xmlns:r="http://schemas.openxmlformats.org/officeDocument/2006/relationships">
+  <p:cSld>
+    <p:spTree>
+      <p:nvGrpSpPr>
+        <p:cNvPr id="1" name=""/>
+        <p:cNvGrpSpPr/>
+        <p:nvPr/>
+      </p:nvGrpSpPr>
+      <p:grpSpPr>
+        <a:xfrm>
+          <a:off x="0" y="0"/>
+          <a:ext cx="0" cy="0"/>
+          <a:chOff x="0" y="0"/>
+          <a:chExt cx="0" cy="0"/>
+        </a:xfrm>
+      </p:grpSpPr>
+      <p:sp>
+        <p:nvSpPr>
+          <p:cNvPr id="2" name="Slide Image Placeholder 1"/>
+          <p:cNvSpPr>
+            <a:spLocks noGrp="1"/>
+          </p:cNvSpPr>
+          <p:nvPr>
+            <p:ph type="sldImg" idx="2"/>
+          </p:nvPr>
+        </p:nvSpPr>
+        <p:spPr/>
+      </p:sp>
+      <p:sp>
+        <p:nvSpPr>
+          <p:cNvPr id="3" name="Notes Placeholder 2"/>
+          <p:cNvSpPr>
+            <a:spLocks noGrp="1"/>
+          </p:cNvSpPr>
+          <p:nvPr>
+            <p:ph type="body" idx="3" sz="quarter"/>
+          </p:nvPr>
+        </p:nvSpPr>
+        <p:spPr/>
+        <p:txBody>
+          <a:bodyPr/>
+          <a:lstStyle/>
+          <a:p>
+            <a:r>
+              <a:t>Добрый день! Меня зовут Егор Некрасов, группа 202. Тема моего доклада — безопасность в условиях Крайнего Севера. Я расскажу о четырёх главных факторах риска: холоде, полярной ночи, изоляции и специфике одежды, а также покажу плакат: карту зон, многослойную систему одежды и график работ и отдыха при низких температурах.</a:t>
+            </a:r>
+          </a:p>
+        </p:txBody>
+      </p:sp>
+      <p:sp>
+        <p:nvSpPr>
+          <p:cNvPr id="4" name="Slide Number Placeholder 3"/>
+          <p:cNvSpPr>
+            <a:spLocks noGrp="1"/>
+          </p:cNvSpPr>
+          <p:nvPr>
+            <p:ph type="sldNum" idx="5" sz="quarter"/>
+          </p:nvPr>
+        </p:nvSpPr>
+        <p:spPr/>
+      </p:sp>
+    </p:spTree>
+  </p:cSld>
+  <p:clrMapOvr>
+    <a:masterClrMapping/>
+  </p:clrMapOvr>
+</p:notes>
+</file>
+
+<file path=ppt/notesSlides/notesSlide15.xml><?xml version="1.0" encoding="utf-8"?>
+<p:notes xmlns:a="http://schemas.openxmlformats.org/drawingml/2006/main" xmlns:p="http://schemas.openxmlformats.org/presentationml/2006/main" xmlns:r="http://schemas.openxmlformats.org/officeDocument/2006/relationships">
+  <p:cSld>
+    <p:spTree>
+      <p:nvGrpSpPr>
+        <p:cNvPr id="1" name=""/>
+        <p:cNvGrpSpPr/>
+        <p:nvPr/>
+      </p:nvGrpSpPr>
+      <p:grpSpPr>
+        <a:xfrm>
+          <a:off x="0" y="0"/>
+          <a:ext cx="0" cy="0"/>
+          <a:chOff x="0" y="0"/>
+          <a:chExt cx="0" cy="0"/>
+        </a:xfrm>
+      </p:grpSpPr>
+      <p:sp>
+        <p:nvSpPr>
+          <p:cNvPr id="2" name="Slide Image Placeholder 1"/>
+          <p:cNvSpPr>
+            <a:spLocks noGrp="1"/>
+          </p:cNvSpPr>
+          <p:nvPr>
+            <p:ph type="sldImg" idx="2"/>
+          </p:nvPr>
+        </p:nvSpPr>
+        <p:spPr/>
+      </p:sp>
+      <p:sp>
+        <p:nvSpPr>
+          <p:cNvPr id="3" name="Notes Placeholder 2"/>
+          <p:cNvSpPr>
+            <a:spLocks noGrp="1"/>
+          </p:cNvSpPr>
+          <p:nvPr>
+            <p:ph type="body" idx="3" sz="quarter"/>
+          </p:nvPr>
+        </p:nvSpPr>
+        <p:spPr/>
+        <p:txBody>
+          <a:bodyPr/>
+          <a:lstStyle/>
+          <a:p>
+            <a:r>
+              <a:t>Север — это не просто «очень холодно». Это сочетание факторов, которые усиливают друг друга. В Оймяконе зафиксирован минимум −67,7 °C. В Норильске полярная ночь длится около 45 суток. Ветер в 10 метров в секунду превращает −20 °C в ощущаемые примерно −33 °C. А помощь может быть в часах или сутках пути, поэтому при выезде нужен аварийный запас минимум на трое суток. Дальше по плану: карта зон, холод, полярная ночь, изоляция, одежда и график работ.</a:t>
+            </a:r>
+          </a:p>
+        </p:txBody>
+      </p:sp>
+      <p:sp>
+        <p:nvSpPr>
+          <p:cNvPr id="4" name="Slide Number Placeholder 3"/>
+          <p:cNvSpPr>
+            <a:spLocks noGrp="1"/>
+          </p:cNvSpPr>
+          <p:nvPr>
+            <p:ph type="sldNum" idx="5" sz="quarter"/>
+          </p:nvPr>
+        </p:nvSpPr>
+        <p:spPr/>
+      </p:sp>
+    </p:spTree>
+  </p:cSld>
+  <p:clrMapOvr>
+    <a:masterClrMapping/>
+  </p:clrMapOvr>
+</p:notes>
+</file>
+
+<file path=ppt/notesSlides/notesSlide16.xml><?xml version="1.0" encoding="utf-8"?>
+<p:notes xmlns:a="http://schemas.openxmlformats.org/drawingml/2006/main" xmlns:p="http://schemas.openxmlformats.org/presentationml/2006/main" xmlns:r="http://schemas.openxmlformats.org/officeDocument/2006/relationships">
+  <p:cSld>
+    <p:spTree>
+      <p:nvGrpSpPr>
+        <p:cNvPr id="1" name=""/>
+        <p:cNvGrpSpPr/>
+        <p:nvPr/>
+      </p:nvGrpSpPr>
+      <p:grpSpPr>
+        <a:xfrm>
+          <a:off x="0" y="0"/>
+          <a:ext cx="0" cy="0"/>
+          <a:chOff x="0" y="0"/>
+          <a:chExt cx="0" cy="0"/>
+        </a:xfrm>
+      </p:grpSpPr>
+      <p:sp>
+        <p:nvSpPr>
+          <p:cNvPr id="2" name="Slide Image Placeholder 1"/>
+          <p:cNvSpPr>
+            <a:spLocks noGrp="1"/>
+          </p:cNvSpPr>
+          <p:nvPr>
+            <p:ph type="sldImg" idx="2"/>
+          </p:nvPr>
+        </p:nvSpPr>
+        <p:spPr/>
+      </p:sp>
+      <p:sp>
+        <p:nvSpPr>
+          <p:cNvPr id="3" name="Notes Placeholder 2"/>
+          <p:cNvSpPr>
+            <a:spLocks noGrp="1"/>
+          </p:cNvSpPr>
+          <p:nvPr>
+            <p:ph type="body" idx="3" sz="quarter"/>
+          </p:nvPr>
+        </p:nvSpPr>
+        <p:spPr/>
+        <p:txBody>
+          <a:bodyPr/>
+          <a:lstStyle/>
+          <a:p>
+            <a:r>
+              <a:t>Это схема в проекции от Северного полюса: нуль меридиана внизу, Россия справа и сверху. Тёмный центр — Арктика с самыми суровыми условиями: полярная ночь больше ста суток, зимой до −40…−55 °C, пурга. Жёлтое кольцо — территории за Полярным кругом, 66,5° северной широты: там полярная ночь и полярный день. Светлое кольцо — районы Крайнего Севера и приравненные местности. Именно тут, в Якутии, бывает до −60 °C. Для сравнения серым показан умеренный пояс. Важно: это схема по широте. Реальный перечень районов Крайнего Севера задан постановлением Совмина СССР № 1029 и более поздними изменениями, и по нему положены гарантии по Трудовому кодексу. Границы климата зависят ещё от рельефа и удалённости от моря.</a:t>
+            </a:r>
+          </a:p>
+        </p:txBody>
+      </p:sp>
+      <p:sp>
+        <p:nvSpPr>
+          <p:cNvPr id="4" name="Slide Number Placeholder 3"/>
+          <p:cNvSpPr>
+            <a:spLocks noGrp="1"/>
+          </p:cNvSpPr>
+          <p:nvPr>
+            <p:ph type="sldNum" idx="5" sz="quarter"/>
+          </p:nvPr>
+        </p:nvSpPr>
+        <p:spPr/>
+      </p:sp>
+    </p:spTree>
+  </p:cSld>
+  <p:clrMapOvr>
+    <a:masterClrMapping/>
+  </p:clrMapOvr>
+</p:notes>
+</file>
+
+<file path=ppt/notesSlides/notesSlide17.xml><?xml version="1.0" encoding="utf-8"?>
+<p:notes xmlns:a="http://schemas.openxmlformats.org/drawingml/2006/main" xmlns:p="http://schemas.openxmlformats.org/presentationml/2006/main" xmlns:r="http://schemas.openxmlformats.org/officeDocument/2006/relationships">
+  <p:cSld>
+    <p:spTree>
+      <p:nvGrpSpPr>
+        <p:cNvPr id="1" name=""/>
+        <p:cNvGrpSpPr/>
+        <p:nvPr/>
+      </p:nvGrpSpPr>
+      <p:grpSpPr>
+        <a:xfrm>
+          <a:off x="0" y="0"/>
+          <a:ext cx="0" cy="0"/>
+          <a:chOff x="0" y="0"/>
+          <a:chExt cx="0" cy="0"/>
+        </a:xfrm>
+      </p:grpSpPr>
+      <p:sp>
+        <p:nvSpPr>
+          <p:cNvPr id="2" name="Slide Image Placeholder 1"/>
+          <p:cNvSpPr>
+            <a:spLocks noGrp="1"/>
+          </p:cNvSpPr>
+          <p:nvPr>
+            <p:ph type="sldImg" idx="2"/>
+          </p:nvPr>
+        </p:nvSpPr>
+        <p:spPr/>
+      </p:sp>
+      <p:sp>
+        <p:nvSpPr>
+          <p:cNvPr id="3" name="Notes Placeholder 2"/>
+          <p:cNvSpPr>
+            <a:spLocks noGrp="1"/>
+          </p:cNvSpPr>
+          <p:nvPr>
+            <p:ph type="body" idx="3" sz="quarter"/>
+          </p:nvPr>
+        </p:nvSpPr>
+        <p:spPr/>
+        <p:txBody>
+          <a:bodyPr/>
+          <a:lstStyle/>
+          <a:p>
+            <a:r>
+              <a:t>Холод опасен несколькими способами. Первое — переохлаждение: температура тела падает ниже 35 °C, появляются дрожь, апатия и спутанность сознания, потом человек теряет сознание. Второе — отморожения: чаще всего страдают нос, щёки, уши и пальцы, кожа белеет и перестаёт чувствовать. Третье — ветер и метель: ветер резко увеличивает потерю тепла, а в пургу пропадает видимость. Четвёртое — техника и материалы: металл прилипает к коже, сталь и пластик становятся хрупкими, батареи быстро садятся. В таблице справа видно, как ветер меняет ощущения: при −20 °C и ветре 10 м/с ощущается около −34 °C. Когда ощущаемая температура ниже −40 °C, открытая кожа может обморозиться за 10–30 минут.</a:t>
+            </a:r>
+          </a:p>
+        </p:txBody>
+      </p:sp>
+      <p:sp>
+        <p:nvSpPr>
+          <p:cNvPr id="4" name="Slide Number Placeholder 3"/>
+          <p:cNvSpPr>
+            <a:spLocks noGrp="1"/>
+          </p:cNvSpPr>
+          <p:nvPr>
+            <p:ph type="sldNum" idx="5" sz="quarter"/>
+          </p:nvPr>
+        </p:nvSpPr>
+        <p:spPr/>
+      </p:sp>
+    </p:spTree>
+  </p:cSld>
+  <p:clrMapOvr>
+    <a:masterClrMapping/>
+  </p:clrMapOvr>
+</p:notes>
+</file>
+
+<file path=ppt/notesSlides/notesSlide18.xml><?xml version="1.0" encoding="utf-8"?>
+<p:notes xmlns:a="http://schemas.openxmlformats.org/drawingml/2006/main" xmlns:p="http://schemas.openxmlformats.org/presentationml/2006/main" xmlns:r="http://schemas.openxmlformats.org/officeDocument/2006/relationships">
+  <p:cSld>
+    <p:spTree>
+      <p:nvGrpSpPr>
+        <p:cNvPr id="1" name=""/>
+        <p:cNvGrpSpPr/>
+        <p:nvPr/>
+      </p:nvGrpSpPr>
+      <p:grpSpPr>
+        <a:xfrm>
+          <a:off x="0" y="0"/>
+          <a:ext cx="0" cy="0"/>
+          <a:chOff x="0" y="0"/>
+          <a:chExt cx="0" cy="0"/>
+        </a:xfrm>
+      </p:grpSpPr>
+      <p:sp>
+        <p:nvSpPr>
+          <p:cNvPr id="2" name="Slide Image Placeholder 1"/>
+          <p:cNvSpPr>
+            <a:spLocks noGrp="1"/>
+          </p:cNvSpPr>
+          <p:nvPr>
+            <p:ph type="sldImg" idx="2"/>
+          </p:nvPr>
+        </p:nvSpPr>
+        <p:spPr/>
+      </p:sp>
+      <p:sp>
+        <p:nvSpPr>
+          <p:cNvPr id="3" name="Notes Placeholder 2"/>
+          <p:cNvSpPr>
+            <a:spLocks noGrp="1"/>
+          </p:cNvSpPr>
+          <p:nvPr>
+            <p:ph type="body" idx="3" sz="quarter"/>
+          </p:nvPr>
+        </p:nvSpPr>
+        <p:spPr/>
+        <p:txBody>
+          <a:bodyPr/>
+          <a:lstStyle/>
+          <a:p>
+            <a:r>
+              <a:t>Полярная ночь — это период, когда солнце не поднимается над горизонтом. В Мурманске она длится около 40 суток, в Норильске около 45, в Диксоне около 80, а на арктических островах может превышать 100. Опасность в том, что сбивается суточный ритм: человек сонлив, внимание падает. В темноте растёт число травм, падений и аварий, легко потерять ориентацию, особенно в пургу. Возможна сезонная депрессия и раздражительность. Что делать: иметь налобный фонарь и держать запасные батареи в тепле, использовать светоотражающие элементы и вешки на маршруте, соблюдать режим сна, обеспечить яркий свет в помещении. Витамин D и светотерапию применяют только по рекомендации врача.</a:t>
+            </a:r>
+          </a:p>
+        </p:txBody>
+      </p:sp>
+      <p:sp>
+        <p:nvSpPr>
+          <p:cNvPr id="4" name="Slide Number Placeholder 3"/>
+          <p:cNvSpPr>
+            <a:spLocks noGrp="1"/>
+          </p:cNvSpPr>
+          <p:nvPr>
+            <p:ph type="sldNum" idx="5" sz="quarter"/>
+          </p:nvPr>
+        </p:nvSpPr>
+        <p:spPr/>
+      </p:sp>
+    </p:spTree>
+  </p:cSld>
+  <p:clrMapOvr>
+    <a:masterClrMapping/>
+  </p:clrMapOvr>
+</p:notes>
+</file>
+
+<file path=ppt/notesSlides/notesSlide19.xml><?xml version="1.0" encoding="utf-8"?>
+<p:notes xmlns:a="http://schemas.openxmlformats.org/drawingml/2006/main" xmlns:p="http://schemas.openxmlformats.org/presentationml/2006/main" xmlns:r="http://schemas.openxmlformats.org/officeDocument/2006/relationships">
+  <p:cSld>
+    <p:spTree>
+      <p:nvGrpSpPr>
+        <p:cNvPr id="1" name=""/>
+        <p:cNvGrpSpPr/>
+        <p:nvPr/>
+      </p:nvGrpSpPr>
+      <p:grpSpPr>
+        <a:xfrm>
+          <a:off x="0" y="0"/>
+          <a:ext cx="0" cy="0"/>
+          <a:chOff x="0" y="0"/>
+          <a:chExt cx="0" cy="0"/>
+        </a:xfrm>
+      </p:grpSpPr>
+      <p:sp>
+        <p:nvSpPr>
+          <p:cNvPr id="2" name="Slide Image Placeholder 1"/>
+          <p:cNvSpPr>
+            <a:spLocks noGrp="1"/>
+          </p:cNvSpPr>
+          <p:nvPr>
+            <p:ph type="sldImg" idx="2"/>
+          </p:nvPr>
+        </p:nvSpPr>
+        <p:spPr/>
+      </p:sp>
+      <p:sp>
+        <p:nvSpPr>
+          <p:cNvPr id="3" name="Notes Placeholder 2"/>
+          <p:cNvSpPr>
+            <a:spLocks noGrp="1"/>
+          </p:cNvSpPr>
+          <p:nvPr>
+            <p:ph type="body" idx="3" sz="quarter"/>
+          </p:nvPr>
+        </p:nvSpPr>
+        <p:spPr/>
+        <p:txBody>
+          <a:bodyPr/>
+          <a:lstStyle/>
+          <a:p>
+            <a:r>
+              <a:t>Изоляция — это удалённость от помощи и от привычной жизни. Риски: рядом нет врача и спасателей, помощь идёт часами и сутками; нет сотовой связи, нужны рация и спутниковый телефон; в небольшой группе из-за тесноты, усталости и однообразия возникают конфликты; нарушается сон. Меры: правило «не один» — выезды и работа минимум вдвоём; план маршрута сдаётся диспетчеру, и связь идёт по графику; автономный запас еды, топлива и тепла и аптечка минимум на 72 часа; режим дня, распределение обязанностей и общение внутри группы. Главное правило: никто не выходит в одиночку, без связи и без сообщённого маршрута.</a:t>
+            </a:r>
+          </a:p>
+        </p:txBody>
+      </p:sp>
+      <p:sp>
+        <p:nvSpPr>
+          <p:cNvPr id="4" name="Slide Number Placeholder 3"/>
+          <p:cNvSpPr>
+            <a:spLocks noGrp="1"/>
+          </p:cNvSpPr>
+          <p:nvPr>
+            <p:ph type="sldNum" idx="5" sz="quarter"/>
+          </p:nvPr>
+        </p:nvSpPr>
+        <p:spPr/>
+      </p:sp>
+    </p:spTree>
+  </p:cSld>
+  <p:clrMapOvr>
+    <a:masterClrMapping/>
+  </p:clrMapOvr>
+</p:notes>
+</file>
+
+<file path=ppt/notesSlides/notesSlide20.xml><?xml version="1.0" encoding="utf-8"?>
+<p:notes xmlns:a="http://schemas.openxmlformats.org/drawingml/2006/main" xmlns:p="http://schemas.openxmlformats.org/presentationml/2006/main" xmlns:r="http://schemas.openxmlformats.org/officeDocument/2006/relationships">
+  <p:cSld>
+    <p:spTree>
+      <p:nvGrpSpPr>
+        <p:cNvPr id="1" name=""/>
+        <p:cNvGrpSpPr/>
+        <p:nvPr/>
+      </p:nvGrpSpPr>
+      <p:grpSpPr>
+        <a:xfrm>
+          <a:off x="0" y="0"/>
+          <a:ext cx="0" cy="0"/>
+          <a:chOff x="0" y="0"/>
+          <a:chExt cx="0" cy="0"/>
+        </a:xfrm>
+      </p:grpSpPr>
+      <p:sp>
+        <p:nvSpPr>
+          <p:cNvPr id="2" name="Slide Image Placeholder 1"/>
+          <p:cNvSpPr>
+            <a:spLocks noGrp="1"/>
+          </p:cNvSpPr>
+          <p:nvPr>
+            <p:ph type="sldImg" idx="2"/>
+          </p:nvPr>
+        </p:nvSpPr>
+        <p:spPr/>
+      </p:sp>
+      <p:sp>
+        <p:nvSpPr>
+          <p:cNvPr id="3" name="Notes Placeholder 2"/>
+          <p:cNvSpPr>
+            <a:spLocks noGrp="1"/>
+          </p:cNvSpPr>
+          <p:nvPr>
+            <p:ph type="body" idx="3" sz="quarter"/>
+          </p:nvPr>
+        </p:nvSpPr>
+        <p:spPr/>
+        <p:txBody>
+          <a:bodyPr/>
+          <a:lstStyle/>
+          <a:p>
+            <a:r>
+              <a:t>Основа защиты от холода — три слоя. Первый, базовый, отводит пот от кожи: синтетика или тонкая мериносовая шерсть плотно к телу. Хлопок не подходит: мокрый, он остывает. Второй слой утепляет, задерживая воздух: флис, шерсть, пух, синтетический утеплитель. Слоёв может быть несколько, но одежда не должна пережимать, потому что тепло — это воздух. Третий слой защищает от ветра и влаги: парка или комбинезон с капюшоном, регулируемыми манжетами и поясом. Важна вентиляция через молнии, чтобы не вспотеть. Лучше немного расстегнуться, чем намокнуть: мокрая одежда в мороз опаснее лёгкого озноба.</a:t>
+            </a:r>
+          </a:p>
+        </p:txBody>
+      </p:sp>
+      <p:sp>
+        <p:nvSpPr>
+          <p:cNvPr id="4" name="Slide Number Placeholder 3"/>
+          <p:cNvSpPr>
+            <a:spLocks noGrp="1"/>
+          </p:cNvSpPr>
+          <p:nvPr>
+            <p:ph type="sldNum" idx="5" sz="quarter"/>
+          </p:nvPr>
+        </p:nvSpPr>
+        <p:spPr/>
+      </p:sp>
+    </p:spTree>
+  </p:cSld>
+  <p:clrMapOvr>
+    <a:masterClrMapping/>
+  </p:clrMapOvr>
+</p:notes>
+</file>
+
+<file path=ppt/notesSlides/notesSlide21.xml><?xml version="1.0" encoding="utf-8"?>
+<p:notes xmlns:a="http://schemas.openxmlformats.org/drawingml/2006/main" xmlns:p="http://schemas.openxmlformats.org/presentationml/2006/main" xmlns:r="http://schemas.openxmlformats.org/officeDocument/2006/relationships">
+  <p:cSld>
+    <p:spTree>
+      <p:nvGrpSpPr>
+        <p:cNvPr id="1" name=""/>
+        <p:cNvGrpSpPr/>
+        <p:nvPr/>
+      </p:nvGrpSpPr>
+      <p:grpSpPr>
+        <a:xfrm>
+          <a:off x="0" y="0"/>
+          <a:ext cx="0" cy="0"/>
+          <a:chOff x="0" y="0"/>
+          <a:chExt cx="0" cy="0"/>
+        </a:xfrm>
+      </p:grpSpPr>
+      <p:sp>
+        <p:nvSpPr>
+          <p:cNvPr id="2" name="Slide Image Placeholder 1"/>
+          <p:cNvSpPr>
+            <a:spLocks noGrp="1"/>
+          </p:cNvSpPr>
+          <p:nvPr>
+            <p:ph type="sldImg" idx="2"/>
+          </p:nvPr>
+        </p:nvSpPr>
+        <p:spPr/>
+      </p:sp>
+      <p:sp>
+        <p:nvSpPr>
+          <p:cNvPr id="3" name="Notes Placeholder 2"/>
+          <p:cNvSpPr>
+            <a:spLocks noGrp="1"/>
+          </p:cNvSpPr>
+          <p:nvPr>
+            <p:ph type="body" idx="3" sz="quarter"/>
+          </p:nvPr>
+        </p:nvSpPr>
+        <p:spPr/>
+        <p:txBody>
+          <a:bodyPr/>
+          <a:lstStyle/>
+          <a:p>
+            <a:r>
+              <a:t>Теперь о специфике северной одежды. Голова и лицо: шапка с ветрозащитой или балаклава, капюшон с меховой оторочкой, она не обмерзает от дыхания, тёмные очки от снежной слепоты. Не оставлять уши открытыми. Руки: рукавицы тёплее перчаток, внутри тонкие перчатки-вкладыши, запасная пара обязательна. Нельзя трогать голой рукой металл. Ноги: обувь на 1–1,5 размера больше, тёплые стельки, две пары носков, не сдавливающих ногу. Тесная и влажная обувь ведёт к отморожению. Корпус: свободный крой, регулировка манжет, пояса и капюшона; джинсы и хлопок на морозе не подходят. И главное правило пота: раньше расстёгиваться, чем вспотеть.</a:t>
+            </a:r>
+          </a:p>
+        </p:txBody>
+      </p:sp>
+      <p:sp>
+        <p:nvSpPr>
+          <p:cNvPr id="4" name="Slide Number Placeholder 3"/>
+          <p:cNvSpPr>
+            <a:spLocks noGrp="1"/>
+          </p:cNvSpPr>
+          <p:nvPr>
+            <p:ph type="sldNum" idx="5" sz="quarter"/>
+          </p:nvPr>
+        </p:nvSpPr>
+        <p:spPr/>
+      </p:sp>
+    </p:spTree>
+  </p:cSld>
+  <p:clrMapOvr>
+    <a:masterClrMapping/>
+  </p:clrMapOvr>
+</p:notes>
+</file>
+
+<file path=ppt/notesSlides/notesSlide22.xml><?xml version="1.0" encoding="utf-8"?>
+<p:notes xmlns:a="http://schemas.openxmlformats.org/drawingml/2006/main" xmlns:p="http://schemas.openxmlformats.org/presentationml/2006/main" xmlns:r="http://schemas.openxmlformats.org/officeDocument/2006/relationships">
+  <p:cSld>
+    <p:spTree>
+      <p:nvGrpSpPr>
+        <p:cNvPr id="1" name=""/>
+        <p:cNvGrpSpPr/>
+        <p:nvPr/>
+      </p:nvGrpSpPr>
+      <p:grpSpPr>
+        <a:xfrm>
+          <a:off x="0" y="0"/>
+          <a:ext cx="0" cy="0"/>
+          <a:chOff x="0" y="0"/>
+          <a:chExt cx="0" cy="0"/>
+        </a:xfrm>
+      </p:grpSpPr>
+      <p:sp>
+        <p:nvSpPr>
+          <p:cNvPr id="2" name="Slide Image Placeholder 1"/>
+          <p:cNvSpPr>
+            <a:spLocks noGrp="1"/>
+          </p:cNvSpPr>
+          <p:nvPr>
+            <p:ph type="sldImg" idx="2"/>
+          </p:nvPr>
+        </p:nvSpPr>
+        <p:spPr/>
+      </p:sp>
+      <p:sp>
+        <p:nvSpPr>
+          <p:cNvPr id="3" name="Notes Placeholder 2"/>
+          <p:cNvSpPr>
+            <a:spLocks noGrp="1"/>
+          </p:cNvSpPr>
+          <p:nvPr>
+            <p:ph type="body" idx="3" sz="quarter"/>
+          </p:nvPr>
+        </p:nvSpPr>
+        <p:spPr/>
+        <p:txBody>
+          <a:bodyPr/>
+          <a:lstStyle/>
+          <a:p>
+            <a:r>
+              <a:t>Это ориентировочный график. При температуре от 0 до −10 °C можно работать около двух часов подряд и греться около 10 минут. От −10 до −20: 90 минут работы и 15 минут обогрева. От −20 до −30: час работы и 15 минут обогрева. От −30 до −40: 45 минут и 20 минут. От −40 до −50: около 30 минут работы и 20 минут в тепле. Ниже −50 °C открытые работы прекращают, кроме аварийных. Ниже −30 °C работают парами и следят друг за другом: лицо и руки. Если ветер 10 м/с и больше, температуру считают на ступень ниже. Тёплое помещение должно быть +21…+25 °C, с горячим питьём и сушкой одежды. Внизу пример смены при −30…−40 °C: четыре блока по 45 минут, между ними обогрев, а посередине час обеда в тепле. Точные режимы определяет МР 2.2.7.2129-06 и локальные акты предприятия.</a:t>
+            </a:r>
+          </a:p>
+        </p:txBody>
+      </p:sp>
+      <p:sp>
+        <p:nvSpPr>
+          <p:cNvPr id="4" name="Slide Number Placeholder 3"/>
+          <p:cNvSpPr>
+            <a:spLocks noGrp="1"/>
+          </p:cNvSpPr>
+          <p:nvPr>
+            <p:ph type="sldNum" idx="5" sz="quarter"/>
+          </p:nvPr>
+        </p:nvSpPr>
+        <p:spPr/>
+      </p:sp>
+    </p:spTree>
+  </p:cSld>
+  <p:clrMapOvr>
+    <a:masterClrMapping/>
+  </p:clrMapOvr>
+</p:notes>
+</file>
+
+<file path=ppt/notesSlides/notesSlide23.xml><?xml version="1.0" encoding="utf-8"?>
+<p:notes xmlns:a="http://schemas.openxmlformats.org/drawingml/2006/main" xmlns:p="http://schemas.openxmlformats.org/presentationml/2006/main" xmlns:r="http://schemas.openxmlformats.org/officeDocument/2006/relationships">
+  <p:cSld>
+    <p:spTree>
+      <p:nvGrpSpPr>
+        <p:cNvPr id="1" name=""/>
+        <p:cNvGrpSpPr/>
+        <p:nvPr/>
+      </p:nvGrpSpPr>
+      <p:grpSpPr>
+        <a:xfrm>
+          <a:off x="0" y="0"/>
+          <a:ext cx="0" cy="0"/>
+          <a:chOff x="0" y="0"/>
+          <a:chExt cx="0" cy="0"/>
+        </a:xfrm>
+      </p:grpSpPr>
+      <p:sp>
+        <p:nvSpPr>
+          <p:cNvPr id="2" name="Slide Image Placeholder 1"/>
+          <p:cNvSpPr>
+            <a:spLocks noGrp="1"/>
+          </p:cNvSpPr>
+          <p:nvPr>
+            <p:ph type="sldImg" idx="2"/>
+          </p:nvPr>
+        </p:nvSpPr>
+        <p:spPr/>
+      </p:sp>
+      <p:sp>
+        <p:nvSpPr>
+          <p:cNvPr id="3" name="Notes Placeholder 2"/>
+          <p:cNvSpPr>
+            <a:spLocks noGrp="1"/>
+          </p:cNvSpPr>
+          <p:nvPr>
+            <p:ph type="body" idx="3" sz="quarter"/>
+          </p:nvPr>
+        </p:nvSpPr>
+        <p:spPr/>
+        <p:txBody>
+          <a:bodyPr/>
+          <a:lstStyle/>
+          <a:p>
+            <a:r>
+              <a:t>Плакат собирает главное на одном слайде. Слева карта зон с типичными зимними температурами: около −55 °C в Арктике, −45 за Полярным кругом и до −60 в Якутии. В центре три слоя одежды: база, тепло, защита, и правило «сухо, свободно, слоями, без хлопка». Справа таблица режима работы и обогрева в минутах по диапазонам температур. Внизу девиз плаката: сухо, слоями, парами, по графику, на связи.</a:t>
+            </a:r>
+          </a:p>
+        </p:txBody>
+      </p:sp>
+      <p:sp>
+        <p:nvSpPr>
+          <p:cNvPr id="4" name="Slide Number Placeholder 3"/>
+          <p:cNvSpPr>
+            <a:spLocks noGrp="1"/>
+          </p:cNvSpPr>
+          <p:nvPr>
+            <p:ph type="sldNum" idx="5" sz="quarter"/>
+          </p:nvPr>
+        </p:nvSpPr>
+        <p:spPr/>
+      </p:sp>
+    </p:spTree>
+  </p:cSld>
+  <p:clrMapOvr>
+    <a:masterClrMapping/>
+  </p:clrMapOvr>
+</p:notes>
+</file>
+
+<file path=ppt/notesSlides/notesSlide24.xml><?xml version="1.0" encoding="utf-8"?>
+<p:notes xmlns:a="http://schemas.openxmlformats.org/drawingml/2006/main" xmlns:p="http://schemas.openxmlformats.org/presentationml/2006/main" xmlns:r="http://schemas.openxmlformats.org/officeDocument/2006/relationships">
+  <p:cSld>
+    <p:spTree>
+      <p:nvGrpSpPr>
+        <p:cNvPr id="1" name=""/>
+        <p:cNvGrpSpPr/>
+        <p:nvPr/>
+      </p:nvGrpSpPr>
+      <p:grpSpPr>
+        <a:xfrm>
+          <a:off x="0" y="0"/>
+          <a:ext cx="0" cy="0"/>
+          <a:chOff x="0" y="0"/>
+          <a:chExt cx="0" cy="0"/>
+        </a:xfrm>
+      </p:grpSpPr>
+      <p:sp>
+        <p:nvSpPr>
+          <p:cNvPr id="2" name="Slide Image Placeholder 1"/>
+          <p:cNvSpPr>
+            <a:spLocks noGrp="1"/>
+          </p:cNvSpPr>
+          <p:nvPr>
+            <p:ph type="sldImg" idx="2"/>
+          </p:nvPr>
+        </p:nvSpPr>
+        <p:spPr/>
+      </p:sp>
+      <p:sp>
+        <p:nvSpPr>
+          <p:cNvPr id="3" name="Notes Placeholder 2"/>
+          <p:cNvSpPr>
+            <a:spLocks noGrp="1"/>
+          </p:cNvSpPr>
+          <p:nvPr>
+            <p:ph type="body" idx="3" sz="quarter"/>
+          </p:nvPr>
+        </p:nvSpPr>
+        <p:spPr/>
+        <p:txBody>
+          <a:bodyPr/>
+          <a:lstStyle/>
+          <a:p>
+            <a:r>
+              <a:t>Первая помощь. При переохлаждении: отвести в тепло, снять мокрую одежду, укутать, дать тёплое сладкое питьё, если человек в сознании. Алкоголь не давать и не растирать. Если сознание нарушено — срочно вызывать помощь. При отморожении: уйти в тепло, снять кольца и тесную обувь, не растирать снегом и не греть у огня, согреть тёплой, но не горячей водой, наложить сухую повязку. Обязательно показать врачу, даже если боль прошла. Номер вызова помощи — 112. Не оставляйте пострадавшего одного и сообщите точное место и время холодового воздействия.</a:t>
+            </a:r>
+          </a:p>
+        </p:txBody>
+      </p:sp>
+      <p:sp>
+        <p:nvSpPr>
+          <p:cNvPr id="4" name="Slide Number Placeholder 3"/>
+          <p:cNvSpPr>
+            <a:spLocks noGrp="1"/>
+          </p:cNvSpPr>
+          <p:nvPr>
+            <p:ph type="sldNum" idx="5" sz="quarter"/>
+          </p:nvPr>
+        </p:nvSpPr>
+        <p:spPr/>
+      </p:sp>
+    </p:spTree>
+  </p:cSld>
+  <p:clrMapOvr>
+    <a:masterClrMapping/>
+  </p:clrMapOvr>
+</p:notes>
+</file>
+
+<file path=ppt/notesSlides/notesSlide25.xml><?xml version="1.0" encoding="utf-8"?>
+<p:notes xmlns:a="http://schemas.openxmlformats.org/drawingml/2006/main" xmlns:p="http://schemas.openxmlformats.org/presentationml/2006/main" xmlns:r="http://schemas.openxmlformats.org/officeDocument/2006/relationships">
+  <p:cSld>
+    <p:spTree>
+      <p:nvGrpSpPr>
+        <p:cNvPr id="1" name=""/>
+        <p:cNvGrpSpPr/>
+        <p:nvPr/>
+      </p:nvGrpSpPr>
+      <p:grpSpPr>
+        <a:xfrm>
+          <a:off x="0" y="0"/>
+          <a:ext cx="0" cy="0"/>
+          <a:chOff x="0" y="0"/>
+          <a:chExt cx="0" cy="0"/>
+        </a:xfrm>
+      </p:grpSpPr>
+      <p:sp>
+        <p:nvSpPr>
+          <p:cNvPr id="2" name="Slide Image Placeholder 1"/>
+          <p:cNvSpPr>
+            <a:spLocks noGrp="1"/>
+          </p:cNvSpPr>
+          <p:nvPr>
+            <p:ph type="sldImg" idx="2"/>
+          </p:nvPr>
+        </p:nvSpPr>
+        <p:spPr/>
+      </p:sp>
+      <p:sp>
+        <p:nvSpPr>
+          <p:cNvPr id="3" name="Notes Placeholder 2"/>
+          <p:cNvSpPr>
+            <a:spLocks noGrp="1"/>
+          </p:cNvSpPr>
+          <p:nvPr>
+            <p:ph type="body" idx="3" sz="quarter"/>
+          </p:nvPr>
+        </p:nvSpPr>
+        <p:spPr/>
+        <p:txBody>
+          <a:bodyPr/>
+          <a:lstStyle/>
+          <a:p>
+            <a:r>
+              <a:t>Подведу итоги. Первое: знайте свою зону, от неё зависят холод, полярная ночь и нормы труда. Второе: холод вместе с ветром опаснее, чем показывает термометр. Третье: одевайтесь слоями и держите тело сухим. Четвёртое: работайте по графику с обогревом и в паре. Пятое: в полярную ночь и в изоляции заботьтесь о свете, режиме, связи и запасе. Север не прощает ошибок, поэтому готовиться нужно заранее. Спасибо за внимание!</a:t>
+            </a:r>
+          </a:p>
+        </p:txBody>
+      </p:sp>
+      <p:sp>
+        <p:nvSpPr>
+          <p:cNvPr id="4" name="Slide Number Placeholder 3"/>
+          <p:cNvSpPr>
+            <a:spLocks noGrp="1"/>
+          </p:cNvSpPr>
+          <p:nvPr>
+            <p:ph type="sldNum" idx="5" sz="quarter"/>
+          </p:nvPr>
+        </p:nvSpPr>
+        <p:spPr/>
+      </p:sp>
+    </p:spTree>
+  </p:cSld>
+  <p:clrMapOvr>
+    <a:masterClrMapping/>
+  </p:clrMapOvr>
+</p:notes>
+</file>
+
+<file path=ppt/notesSlides/notesSlide26.xml><?xml version="1.0" encoding="utf-8"?>
+<p:notes xmlns:a="http://schemas.openxmlformats.org/drawingml/2006/main" xmlns:p="http://schemas.openxmlformats.org/presentationml/2006/main" xmlns:r="http://schemas.openxmlformats.org/officeDocument/2006/relationships">
+  <p:cSld>
+    <p:spTree>
+      <p:nvGrpSpPr>
+        <p:cNvPr id="1" name=""/>
+        <p:cNvGrpSpPr/>
+        <p:nvPr/>
+      </p:nvGrpSpPr>
+      <p:grpSpPr>
+        <a:xfrm>
+          <a:off x="0" y="0"/>
+          <a:ext cx="0" cy="0"/>
+          <a:chOff x="0" y="0"/>
+          <a:chExt cx="0" cy="0"/>
+        </a:xfrm>
+      </p:grpSpPr>
+      <p:sp>
+        <p:nvSpPr>
+          <p:cNvPr id="2" name="Slide Image Placeholder 1"/>
+          <p:cNvSpPr>
+            <a:spLocks noGrp="1"/>
+          </p:cNvSpPr>
+          <p:nvPr>
+            <p:ph type="sldImg" idx="2"/>
+          </p:nvPr>
+        </p:nvSpPr>
+        <p:spPr/>
+      </p:sp>
+      <p:sp>
+        <p:nvSpPr>
+          <p:cNvPr id="3" name="Notes Placeholder 2"/>
+          <p:cNvSpPr>
+            <a:spLocks noGrp="1"/>
+          </p:cNvSpPr>
+          <p:nvPr>
+            <p:ph type="body" idx="3" sz="quarter"/>
+          </p:nvPr>
+        </p:nvSpPr>
+        <p:spPr/>
+        <p:txBody>
+          <a:bodyPr/>
+          <a:lstStyle/>
+          <a:p>
+            <a:r>
+              <a:t>При подготовке я опирался на Трудовой кодекс, МР 2.2.7.2129-06 о режимах труда на холоде, перечень районов Крайнего Севера, индекс ветро-холодового охлаждения и данные Росгидромета. Числовые режимы на плакате ориентировочные, перед применением их нужно сверять с действующими нормами.</a:t>
+            </a:r>
+          </a:p>
+        </p:txBody>
+      </p:sp>
+      <p:sp>
+        <p:nvSpPr>
+          <p:cNvPr id="4" name="Slide Number Placeholder 3"/>
+          <p:cNvSpPr>
+            <a:spLocks noGrp="1"/>
+          </p:cNvSpPr>
+          <p:nvPr>
+            <p:ph type="sldNum" idx="5" sz="quarter"/>
+          </p:nvPr>
+        </p:nvSpPr>
+        <p:spPr/>
+      </p:sp>
+    </p:spTree>
+  </p:cSld>
+  <p:clrMapOvr>
+    <a:masterClrMapping/>
+  </p:clrMapOvr>
+</p:notes>
 </file>
 
 <file path=ppt/slideLayouts/slideLayout1.xml><?xml version="1.0" encoding="utf-8"?>

</xml_diff>

<commit_message>
Fix inconsistent figures, enlarge text on poster and tables
Co-Authored-By: Claude Sonnet 5.5 <noreply@anthropic.com>
Claude-Session: https://claude.ai/code/session_0119SPq8eRKyTVqhrTEFqUAc
</commit_message>
<xml_diff>
--- a/out/Безопасность_на_Крайнем_Севере.pptx
+++ b/out/Безопасность_на_Крайнем_Севере.pptx
@@ -857,7 +857,7 @@
           <a:lstStyle/>
           <a:p>
             <a:r>
-              <a:t>Север — это не просто «очень холодно». Это сочетание факторов, которые усиливают друг друга. В Оймяконе зафиксирован минимум −67,7 °C. В Норильске полярная ночь длится около 45 суток. Ветер в 10 метров в секунду превращает −20 °C в ощущаемые примерно −33 °C. А помощь может быть в часах или сутках пути, поэтому при выезде нужен аварийный запас минимум на трое суток. Дальше по плану: карта зон, холод, полярная ночь, изоляция, одежда и график работ.</a:t>
+              <a:t>Север — это не просто «очень холодно». Это сочетание факторов, которые усиливают друг друга. В Оймяконе зафиксирован минимум −67,7 °C. В Норильске полярная ночь длится около 45 суток. Ветер в 10 метров в секунду превращает −20 °C в ощущаемые примерно −34 °C. А помощь может быть в часах или сутках пути, поэтому при выезде нужен аварийный запас минимум на трое суток. Дальше по плану: карта зон, холод, полярная ночь, изоляция, одежда и график работ.</a:t>
             </a:r>
           </a:p>
         </p:txBody>
@@ -6809,11 +6809,11 @@
           <a:p>
             <a:pPr algn="l">
               <a:spcAft>
-                <a:spcPts val="1200"/>
+                <a:spcPts val="1400"/>
               </a:spcAft>
             </a:pPr>
             <a:r>
-              <a:rPr sz="1400" b="1">
+              <a:rPr sz="1600" b="1">
                 <a:solidFill>
                   <a:srgbClr val="2B2B2B"/>
                 </a:solidFill>
@@ -6822,7 +6822,7 @@
               <a:t>Арктика: </a:t>
             </a:r>
             <a:r>
-              <a:rPr sz="1400" b="0">
+              <a:rPr sz="1600" b="0">
                 <a:solidFill>
                   <a:srgbClr val="4B4B4B"/>
                 </a:solidFill>
@@ -6831,6 +6831,104 @@
               <a:t>−40…−55 °C, ночь 80–120 сут</a:t>
             </a:r>
           </a:p>
+          <a:p>
+            <a:pPr algn="l">
+              <a:spcAft>
+                <a:spcPts val="1400"/>
+              </a:spcAft>
+            </a:pPr>
+            <a:r>
+              <a:rPr sz="1600" b="1">
+                <a:solidFill>
+                  <a:srgbClr val="2B2B2B"/>
+                </a:solidFill>
+                <a:latin typeface="Calibri"/>
+              </a:rPr>
+              <a:t>За Полярным кругом: </a:t>
+            </a:r>
+            <a:r>
+              <a:rPr sz="1600" b="0">
+                <a:solidFill>
+                  <a:srgbClr val="4B4B4B"/>
+                </a:solidFill>
+                <a:latin typeface="Calibri"/>
+              </a:rPr>
+              <a:t>−30…−45 °C, ночь до 45 сут</a:t>
+            </a:r>
+          </a:p>
+          <a:p>
+            <a:pPr algn="l">
+              <a:spcAft>
+                <a:spcPts val="1400"/>
+              </a:spcAft>
+            </a:pPr>
+            <a:r>
+              <a:rPr sz="1600" b="1">
+                <a:solidFill>
+                  <a:srgbClr val="2B2B2B"/>
+                </a:solidFill>
+                <a:latin typeface="Calibri"/>
+              </a:rPr>
+              <a:t>Крайний Север: </a:t>
+            </a:r>
+            <a:r>
+              <a:rPr sz="1600" b="0">
+                <a:solidFill>
+                  <a:srgbClr val="4B4B4B"/>
+                </a:solidFill>
+                <a:latin typeface="Calibri"/>
+              </a:rPr>
+              <a:t>до −50…−67 °C</a:t>
+            </a:r>
+          </a:p>
+          <a:p>
+            <a:pPr algn="l">
+              <a:spcAft>
+                <a:spcPts val="1400"/>
+              </a:spcAft>
+            </a:pPr>
+            <a:r>
+              <a:rPr sz="1600" b="1">
+                <a:solidFill>
+                  <a:srgbClr val="2B2B2B"/>
+                </a:solidFill>
+                <a:latin typeface="Calibri"/>
+              </a:rPr>
+              <a:t>Приравненные: </a:t>
+            </a:r>
+            <a:r>
+              <a:rPr sz="1600" b="0">
+                <a:solidFill>
+                  <a:srgbClr val="4B4B4B"/>
+                </a:solidFill>
+                <a:latin typeface="Calibri"/>
+              </a:rPr>
+              <a:t>−25…−40 °C, долгая зима</a:t>
+            </a:r>
+          </a:p>
+        </p:txBody>
+      </p:sp>
+      <p:sp>
+        <p:nvSpPr>
+          <p:cNvPr id="17" name="Слои на плакате"/>
+          <p:cNvSpPr txBox="1"/>
+          <p:nvPr/>
+        </p:nvSpPr>
+        <p:spPr>
+          <a:xfrm>
+            <a:off x="4503420" y="2286000"/>
+            <a:ext cx="3200400" cy="3108960"/>
+          </a:xfrm>
+          <a:prstGeom prst="rect">
+            <a:avLst/>
+          </a:prstGeom>
+          <a:noFill/>
+        </p:spPr>
+        <p:txBody>
+          <a:bodyPr wrap="square" anchor="t" lIns="18288" rIns="18288" tIns="27432" bIns="27432">
+            <a:spAutoFit/>
+          </a:bodyPr>
+          <a:lstStyle/>
           <a:p>
             <a:pPr algn="l">
               <a:spcAft>
@@ -6838,22 +6936,22 @@
               </a:spcAft>
             </a:pPr>
             <a:r>
-              <a:rPr sz="1400" b="1">
+              <a:rPr sz="1600" b="1">
                 <a:solidFill>
                   <a:srgbClr val="2B2B2B"/>
                 </a:solidFill>
                 <a:latin typeface="Calibri"/>
               </a:rPr>
-              <a:t>За Полярным кругом: </a:t>
-            </a:r>
-            <a:r>
-              <a:rPr sz="1400" b="0">
+              <a:t>1 · база: </a:t>
+            </a:r>
+            <a:r>
+              <a:rPr sz="1600" b="0">
                 <a:solidFill>
                   <a:srgbClr val="4B4B4B"/>
                 </a:solidFill>
                 <a:latin typeface="Calibri"/>
               </a:rPr>
-              <a:t>−30…−45 °C, ночь до 45 сут</a:t>
+              <a:t>синтетика или шерсть</a:t>
             </a:r>
           </a:p>
           <a:p>
@@ -6863,22 +6961,22 @@
               </a:spcAft>
             </a:pPr>
             <a:r>
-              <a:rPr sz="1400" b="1">
+              <a:rPr sz="1600" b="1">
                 <a:solidFill>
                   <a:srgbClr val="2B2B2B"/>
                 </a:solidFill>
                 <a:latin typeface="Calibri"/>
               </a:rPr>
-              <a:t>Крайний Север: </a:t>
-            </a:r>
-            <a:r>
-              <a:rPr sz="1400" b="0">
+              <a:t>2 · тепло: </a:t>
+            </a:r>
+            <a:r>
+              <a:rPr sz="1600" b="0">
                 <a:solidFill>
                   <a:srgbClr val="4B4B4B"/>
                 </a:solidFill>
                 <a:latin typeface="Calibri"/>
               </a:rPr>
-              <a:t>до −50…−67 °C</a:t>
+              <a:t>флис, пух, шерсть</a:t>
             </a:r>
           </a:p>
           <a:p>
@@ -6888,164 +6986,66 @@
               </a:spcAft>
             </a:pPr>
             <a:r>
-              <a:rPr sz="1400" b="1">
+              <a:rPr sz="1600" b="1">
                 <a:solidFill>
                   <a:srgbClr val="2B2B2B"/>
                 </a:solidFill>
                 <a:latin typeface="Calibri"/>
               </a:rPr>
-              <a:t>Приравненные: </a:t>
-            </a:r>
-            <a:r>
-              <a:rPr sz="1400" b="0">
+              <a:t>3 · защита: </a:t>
+            </a:r>
+            <a:r>
+              <a:rPr sz="1600" b="0">
                 <a:solidFill>
                   <a:srgbClr val="4B4B4B"/>
                 </a:solidFill>
                 <a:latin typeface="Calibri"/>
               </a:rPr>
-              <a:t>−25…−40 °C, долгая зима</a:t>
-            </a:r>
-          </a:p>
-        </p:txBody>
-      </p:sp>
-      <p:sp>
-        <p:nvSpPr>
-          <p:cNvPr id="17" name="Слои на плакате"/>
-          <p:cNvSpPr txBox="1"/>
-          <p:nvPr/>
-        </p:nvSpPr>
-        <p:spPr>
-          <a:xfrm>
-            <a:off x="4503420" y="2286000"/>
-            <a:ext cx="3200400" cy="3108960"/>
-          </a:xfrm>
-          <a:prstGeom prst="rect">
-            <a:avLst/>
-          </a:prstGeom>
-          <a:noFill/>
-        </p:spPr>
-        <p:txBody>
-          <a:bodyPr wrap="square" anchor="t" lIns="18288" rIns="18288" tIns="27432" bIns="27432">
-            <a:spAutoFit/>
-          </a:bodyPr>
-          <a:lstStyle/>
+              <a:t>ветро- и влагозащита</a:t>
+            </a:r>
+          </a:p>
           <a:p>
             <a:pPr algn="l">
               <a:spcAft>
-                <a:spcPts val="1000"/>
+                <a:spcPts val="1200"/>
               </a:spcAft>
             </a:pPr>
             <a:r>
-              <a:rPr sz="1400" b="1">
+              <a:rPr sz="1600" b="1">
                 <a:solidFill>
                   <a:srgbClr val="2B2B2B"/>
                 </a:solidFill>
                 <a:latin typeface="Calibri"/>
               </a:rPr>
-              <a:t>1 · база: </a:t>
-            </a:r>
-            <a:r>
-              <a:rPr sz="1400" b="0">
+              <a:t>Руки и ноги: </a:t>
+            </a:r>
+            <a:r>
+              <a:rPr sz="1600" b="0">
                 <a:solidFill>
                   <a:srgbClr val="4B4B4B"/>
                 </a:solidFill>
                 <a:latin typeface="Calibri"/>
               </a:rPr>
-              <a:t>синтетика или шерсть</a:t>
+              <a:t>рукавицы, обувь на размер больше</a:t>
             </a:r>
           </a:p>
           <a:p>
             <a:pPr algn="l">
               <a:spcAft>
-                <a:spcPts val="1000"/>
+                <a:spcPts val="1200"/>
               </a:spcAft>
             </a:pPr>
             <a:r>
-              <a:rPr sz="1400" b="1">
+              <a:rPr sz="1600" b="1">
                 <a:solidFill>
                   <a:srgbClr val="2B2B2B"/>
                 </a:solidFill>
                 <a:latin typeface="Calibri"/>
               </a:rPr>
-              <a:t>2 · тепло: </a:t>
-            </a:r>
-            <a:r>
-              <a:rPr sz="1400" b="0">
-                <a:solidFill>
-                  <a:srgbClr val="4B4B4B"/>
-                </a:solidFill>
-                <a:latin typeface="Calibri"/>
-              </a:rPr>
-              <a:t>флис, пух, шерсть</a:t>
-            </a:r>
-          </a:p>
-          <a:p>
-            <a:pPr algn="l">
-              <a:spcAft>
-                <a:spcPts val="1000"/>
-              </a:spcAft>
-            </a:pPr>
-            <a:r>
-              <a:rPr sz="1400" b="1">
-                <a:solidFill>
-                  <a:srgbClr val="2B2B2B"/>
-                </a:solidFill>
-                <a:latin typeface="Calibri"/>
-              </a:rPr>
-              <a:t>3 · защита: </a:t>
-            </a:r>
-            <a:r>
-              <a:rPr sz="1400" b="0">
-                <a:solidFill>
-                  <a:srgbClr val="4B4B4B"/>
-                </a:solidFill>
-                <a:latin typeface="Calibri"/>
-              </a:rPr>
-              <a:t>ветро- и влагозащита</a:t>
-            </a:r>
-          </a:p>
-          <a:p>
-            <a:pPr algn="l">
-              <a:spcAft>
-                <a:spcPts val="1000"/>
-              </a:spcAft>
-            </a:pPr>
-            <a:r>
-              <a:rPr sz="1400" b="1">
-                <a:solidFill>
-                  <a:srgbClr val="2B2B2B"/>
-                </a:solidFill>
-                <a:latin typeface="Calibri"/>
-              </a:rPr>
-              <a:t>Руки и ноги: </a:t>
-            </a:r>
-            <a:r>
-              <a:rPr sz="1400" b="0">
-                <a:solidFill>
-                  <a:srgbClr val="4B4B4B"/>
-                </a:solidFill>
-                <a:latin typeface="Calibri"/>
-              </a:rPr>
-              <a:t>рукавицы, обувь на размер больше</a:t>
-            </a:r>
-          </a:p>
-          <a:p>
-            <a:pPr algn="l">
-              <a:spcAft>
-                <a:spcPts val="1000"/>
-              </a:spcAft>
-            </a:pPr>
-            <a:r>
-              <a:rPr sz="1400" b="1">
-                <a:solidFill>
-                  <a:srgbClr val="2B2B2B"/>
-                </a:solidFill>
-                <a:latin typeface="Calibri"/>
-              </a:rPr>
               <a:t>Правило: </a:t>
             </a:r>
             <a:r>
-              <a:rPr sz="1400" b="0">
+              <a:rPr sz="1600" b="0">
                 <a:solidFill>
                   <a:srgbClr val="4B4B4B"/>
                 </a:solidFill>
@@ -9796,7 +9796,7 @@
           <a:p>
             <a:pPr algn="l"/>
             <a:r>
-              <a:rPr sz="1400" b="0">
+              <a:rPr sz="1500" b="0">
                 <a:solidFill>
                   <a:srgbClr val="4B4B4B"/>
                 </a:solidFill>
@@ -9956,13 +9956,13 @@
           <a:p>
             <a:pPr algn="l"/>
             <a:r>
-              <a:rPr sz="1400" b="0">
+              <a:rPr sz="1500" b="0">
                 <a:solidFill>
                   <a:srgbClr val="4B4B4B"/>
                 </a:solidFill>
                 <a:latin typeface="Calibri"/>
               </a:rPr>
-              <a:t>непрерывной полярной ночи в Норильске (около 3 дек — 13 янв)</a:t>
+              <a:t>непрерывной полярной ночи в Норильске (с конца ноября до середины января)</a:t>
             </a:r>
           </a:p>
         </p:txBody>
@@ -10043,7 +10043,7 @@
                 </a:solidFill>
                 <a:latin typeface="Calibri"/>
               </a:rPr>
-              <a:t>≈ −33 °C</a:t>
+              <a:t>≈ −34 °C</a:t>
             </a:r>
           </a:p>
         </p:txBody>
@@ -10116,7 +10116,7 @@
           <a:p>
             <a:pPr algn="l"/>
             <a:r>
-              <a:rPr sz="1400" b="0">
+              <a:rPr sz="1500" b="0">
                 <a:solidFill>
                   <a:srgbClr val="4B4B4B"/>
                 </a:solidFill>
@@ -10276,7 +10276,7 @@
           <a:p>
             <a:pPr algn="l"/>
             <a:r>
-              <a:rPr sz="1400" b="0">
+              <a:rPr sz="1500" b="0">
                 <a:solidFill>
                   <a:srgbClr val="4B4B4B"/>
                 </a:solidFill>
@@ -12478,7 +12478,7 @@
                           </a:solidFill>
                           <a:latin typeface="Calibri"/>
                         </a:rPr>
-                        <a:t>-10 °C</a:t>
+                        <a:t>−10 °C</a:t>
                       </a:r>
                     </a:p>
                   </a:txBody>
@@ -12501,7 +12501,7 @@
                           </a:solidFill>
                           <a:latin typeface="Calibri"/>
                         </a:rPr>
-                        <a:t>-17</a:t>
+                        <a:t>−17</a:t>
                       </a:r>
                     </a:p>
                   </a:txBody>
@@ -12524,7 +12524,7 @@
                           </a:solidFill>
                           <a:latin typeface="Calibri"/>
                         </a:rPr>
-                        <a:t>-20</a:t>
+                        <a:t>−20</a:t>
                       </a:r>
                     </a:p>
                   </a:txBody>
@@ -12547,7 +12547,7 @@
                           </a:solidFill>
                           <a:latin typeface="Calibri"/>
                         </a:rPr>
-                        <a:t>-22</a:t>
+                        <a:t>−22</a:t>
                       </a:r>
                     </a:p>
                   </a:txBody>
@@ -12572,7 +12572,7 @@
                           </a:solidFill>
                           <a:latin typeface="Calibri"/>
                         </a:rPr>
-                        <a:t>-20 °C</a:t>
+                        <a:t>−20 °C</a:t>
                       </a:r>
                     </a:p>
                   </a:txBody>
@@ -12595,7 +12595,7 @@
                           </a:solidFill>
                           <a:latin typeface="Calibri"/>
                         </a:rPr>
-                        <a:t>-30</a:t>
+                        <a:t>−30</a:t>
                       </a:r>
                     </a:p>
                   </a:txBody>
@@ -12618,7 +12618,7 @@
                           </a:solidFill>
                           <a:latin typeface="Calibri"/>
                         </a:rPr>
-                        <a:t>-34</a:t>
+                        <a:t>−34</a:t>
                       </a:r>
                     </a:p>
                   </a:txBody>
@@ -12641,7 +12641,7 @@
                           </a:solidFill>
                           <a:latin typeface="Calibri"/>
                         </a:rPr>
-                        <a:t>-36</a:t>
+                        <a:t>−36</a:t>
                       </a:r>
                     </a:p>
                   </a:txBody>
@@ -12666,7 +12666,7 @@
                           </a:solidFill>
                           <a:latin typeface="Calibri"/>
                         </a:rPr>
-                        <a:t>-30 °C</a:t>
+                        <a:t>−30 °C</a:t>
                       </a:r>
                     </a:p>
                   </a:txBody>
@@ -12689,7 +12689,7 @@
                           </a:solidFill>
                           <a:latin typeface="Calibri"/>
                         </a:rPr>
-                        <a:t>-42</a:t>
+                        <a:t>−42</a:t>
                       </a:r>
                     </a:p>
                   </a:txBody>
@@ -12712,7 +12712,7 @@
                           </a:solidFill>
                           <a:latin typeface="Calibri"/>
                         </a:rPr>
-                        <a:t>-47</a:t>
+                        <a:t>−47</a:t>
                       </a:r>
                     </a:p>
                   </a:txBody>
@@ -12735,7 +12735,7 @@
                           </a:solidFill>
                           <a:latin typeface="Calibri"/>
                         </a:rPr>
-                        <a:t>-50</a:t>
+                        <a:t>−50</a:t>
                       </a:r>
                     </a:p>
                   </a:txBody>
@@ -12760,7 +12760,7 @@
                           </a:solidFill>
                           <a:latin typeface="Calibri"/>
                         </a:rPr>
-                        <a:t>-40 °C</a:t>
+                        <a:t>−40 °C</a:t>
                       </a:r>
                     </a:p>
                   </a:txBody>
@@ -12783,7 +12783,7 @@
                           </a:solidFill>
                           <a:latin typeface="Calibri"/>
                         </a:rPr>
-                        <a:t>-55</a:t>
+                        <a:t>−55</a:t>
                       </a:r>
                     </a:p>
                   </a:txBody>
@@ -12806,7 +12806,7 @@
                           </a:solidFill>
                           <a:latin typeface="Calibri"/>
                         </a:rPr>
-                        <a:t>-60</a:t>
+                        <a:t>−60</a:t>
                       </a:r>
                     </a:p>
                   </a:txBody>
@@ -12829,7 +12829,7 @@
                           </a:solidFill>
                           <a:latin typeface="Calibri"/>
                         </a:rPr>
-                        <a:t>-63</a:t>
+                        <a:t>−63</a:t>
                       </a:r>
                     </a:p>
                   </a:txBody>
@@ -16051,7 +16051,7 @@
                     <a:p>
                       <a:pPr algn="l"/>
                       <a:r>
-                        <a:rPr sz="1400" b="1">
+                        <a:rPr sz="1500" b="1">
                           <a:solidFill>
                             <a:srgbClr val="2B2B2B"/>
                           </a:solidFill>
@@ -16074,7 +16074,7 @@
                     <a:p>
                       <a:pPr algn="l"/>
                       <a:r>
-                        <a:rPr sz="1300" b="0">
+                        <a:rPr sz="1500" b="0">
                           <a:solidFill>
                             <a:srgbClr val="2B2B2B"/>
                           </a:solidFill>
@@ -16097,7 +16097,7 @@
                     <a:p>
                       <a:pPr algn="l"/>
                       <a:r>
-                        <a:rPr sz="1300" b="0">
+                        <a:rPr sz="1500" b="0">
                           <a:solidFill>
                             <a:srgbClr val="2B2B2B"/>
                           </a:solidFill>
@@ -16122,7 +16122,7 @@
                     <a:p>
                       <a:pPr algn="l"/>
                       <a:r>
-                        <a:rPr sz="1400" b="1">
+                        <a:rPr sz="1500" b="1">
                           <a:solidFill>
                             <a:srgbClr val="2B2B2B"/>
                           </a:solidFill>
@@ -16145,7 +16145,7 @@
                     <a:p>
                       <a:pPr algn="l"/>
                       <a:r>
-                        <a:rPr sz="1300" b="0">
+                        <a:rPr sz="1500" b="0">
                           <a:solidFill>
                             <a:srgbClr val="2B2B2B"/>
                           </a:solidFill>
@@ -16168,7 +16168,7 @@
                     <a:p>
                       <a:pPr algn="l"/>
                       <a:r>
-                        <a:rPr sz="1300" b="0">
+                        <a:rPr sz="1500" b="0">
                           <a:solidFill>
                             <a:srgbClr val="2B2B2B"/>
                           </a:solidFill>
@@ -16193,7 +16193,7 @@
                     <a:p>
                       <a:pPr algn="l"/>
                       <a:r>
-                        <a:rPr sz="1400" b="1">
+                        <a:rPr sz="1500" b="1">
                           <a:solidFill>
                             <a:srgbClr val="2B2B2B"/>
                           </a:solidFill>
@@ -16216,7 +16216,7 @@
                     <a:p>
                       <a:pPr algn="l"/>
                       <a:r>
-                        <a:rPr sz="1300" b="0">
+                        <a:rPr sz="1500" b="0">
                           <a:solidFill>
                             <a:srgbClr val="2B2B2B"/>
                           </a:solidFill>
@@ -16239,7 +16239,7 @@
                     <a:p>
                       <a:pPr algn="l"/>
                       <a:r>
-                        <a:rPr sz="1300" b="0">
+                        <a:rPr sz="1500" b="0">
                           <a:solidFill>
                             <a:srgbClr val="2B2B2B"/>
                           </a:solidFill>
@@ -16264,7 +16264,7 @@
                     <a:p>
                       <a:pPr algn="l"/>
                       <a:r>
-                        <a:rPr sz="1400" b="1">
+                        <a:rPr sz="1500" b="1">
                           <a:solidFill>
                             <a:srgbClr val="2B2B2B"/>
                           </a:solidFill>
@@ -16287,7 +16287,7 @@
                     <a:p>
                       <a:pPr algn="l"/>
                       <a:r>
-                        <a:rPr sz="1300" b="0">
+                        <a:rPr sz="1500" b="0">
                           <a:solidFill>
                             <a:srgbClr val="2B2B2B"/>
                           </a:solidFill>
@@ -16310,7 +16310,7 @@
                     <a:p>
                       <a:pPr algn="l"/>
                       <a:r>
-                        <a:rPr sz="1300" b="0">
+                        <a:rPr sz="1500" b="0">
                           <a:solidFill>
                             <a:srgbClr val="2B2B2B"/>
                           </a:solidFill>
@@ -16335,7 +16335,7 @@
                     <a:p>
                       <a:pPr algn="l"/>
                       <a:r>
-                        <a:rPr sz="1400" b="1">
+                        <a:rPr sz="1500" b="1">
                           <a:solidFill>
                             <a:srgbClr val="2B2B2B"/>
                           </a:solidFill>
@@ -16358,7 +16358,7 @@
                     <a:p>
                       <a:pPr algn="l"/>
                       <a:r>
-                        <a:rPr sz="1300" b="0">
+                        <a:rPr sz="1500" b="0">
                           <a:solidFill>
                             <a:srgbClr val="2B2B2B"/>
                           </a:solidFill>
@@ -16381,7 +16381,7 @@
                     <a:p>
                       <a:pPr algn="l"/>
                       <a:r>
-                        <a:rPr sz="1300" b="0">
+                        <a:rPr sz="1500" b="0">
                           <a:solidFill>
                             <a:srgbClr val="2B2B2B"/>
                           </a:solidFill>

</xml_diff>